<commit_message>
pca with different factors
</commit_message>
<xml_diff>
--- a/progress.pptx
+++ b/progress.pptx
@@ -5,7 +5,7 @@
     <p:sldMasterId id="2147483648" r:id="rId1"/>
   </p:sldMasterIdLst>
   <p:notesMasterIdLst>
-    <p:notesMasterId r:id="rId10"/>
+    <p:notesMasterId r:id="rId13"/>
   </p:notesMasterIdLst>
   <p:sldIdLst>
     <p:sldId id="261" r:id="rId2"/>
@@ -16,6 +16,9 @@
     <p:sldId id="265" r:id="rId7"/>
     <p:sldId id="267" r:id="rId8"/>
     <p:sldId id="268" r:id="rId9"/>
+    <p:sldId id="269" r:id="rId10"/>
+    <p:sldId id="270" r:id="rId11"/>
+    <p:sldId id="271" r:id="rId12"/>
   </p:sldIdLst>
   <p:sldSz cx="12192000" cy="6858000"/>
   <p:notesSz cx="6858000" cy="9144000"/>
@@ -114,6 +117,11 @@
       </a:defRPr>
     </a:lvl9pPr>
   </p:defaultTextStyle>
+  <p:extLst>
+    <p:ext uri="{EFAFB233-063F-42B5-8137-9DF3F51BA10A}">
+      <p15:sldGuideLst xmlns:p15="http://schemas.microsoft.com/office/powerpoint/2012/main"/>
+    </p:ext>
+  </p:extLst>
 </p:presentation>
 </file>
 
@@ -199,7 +207,7 @@
           <a:p>
             <a:fld id="{391F0B43-6B19-1044-8D4F-E46BB78FCD8B}" type="datetimeFigureOut">
               <a:rPr lang="de-DE" smtClean="0"/>
-              <a:t>16.01.25</a:t>
+              <a:t>19.01.25</a:t>
             </a:fld>
             <a:endParaRPr lang="de-DE"/>
           </a:p>
@@ -882,7 +890,7 @@
           <a:p>
             <a:fld id="{B202D3EB-434C-7940-89BB-2B1A6C02241D}" type="datetimeFigureOut">
               <a:rPr lang="de-DE" smtClean="0"/>
-              <a:t>16.01.25</a:t>
+              <a:t>19.01.25</a:t>
             </a:fld>
             <a:endParaRPr lang="de-DE"/>
           </a:p>
@@ -1080,7 +1088,7 @@
           <a:p>
             <a:fld id="{B202D3EB-434C-7940-89BB-2B1A6C02241D}" type="datetimeFigureOut">
               <a:rPr lang="de-DE" smtClean="0"/>
-              <a:t>16.01.25</a:t>
+              <a:t>19.01.25</a:t>
             </a:fld>
             <a:endParaRPr lang="de-DE"/>
           </a:p>
@@ -1288,7 +1296,7 @@
           <a:p>
             <a:fld id="{B202D3EB-434C-7940-89BB-2B1A6C02241D}" type="datetimeFigureOut">
               <a:rPr lang="de-DE" smtClean="0"/>
-              <a:t>16.01.25</a:t>
+              <a:t>19.01.25</a:t>
             </a:fld>
             <a:endParaRPr lang="de-DE"/>
           </a:p>
@@ -1486,7 +1494,7 @@
           <a:p>
             <a:fld id="{B202D3EB-434C-7940-89BB-2B1A6C02241D}" type="datetimeFigureOut">
               <a:rPr lang="de-DE" smtClean="0"/>
-              <a:t>16.01.25</a:t>
+              <a:t>19.01.25</a:t>
             </a:fld>
             <a:endParaRPr lang="de-DE"/>
           </a:p>
@@ -1761,7 +1769,7 @@
           <a:p>
             <a:fld id="{B202D3EB-434C-7940-89BB-2B1A6C02241D}" type="datetimeFigureOut">
               <a:rPr lang="de-DE" smtClean="0"/>
-              <a:t>16.01.25</a:t>
+              <a:t>19.01.25</a:t>
             </a:fld>
             <a:endParaRPr lang="de-DE"/>
           </a:p>
@@ -2026,7 +2034,7 @@
           <a:p>
             <a:fld id="{B202D3EB-434C-7940-89BB-2B1A6C02241D}" type="datetimeFigureOut">
               <a:rPr lang="de-DE" smtClean="0"/>
-              <a:t>16.01.25</a:t>
+              <a:t>19.01.25</a:t>
             </a:fld>
             <a:endParaRPr lang="de-DE"/>
           </a:p>
@@ -2438,7 +2446,7 @@
           <a:p>
             <a:fld id="{B202D3EB-434C-7940-89BB-2B1A6C02241D}" type="datetimeFigureOut">
               <a:rPr lang="de-DE" smtClean="0"/>
-              <a:t>16.01.25</a:t>
+              <a:t>19.01.25</a:t>
             </a:fld>
             <a:endParaRPr lang="de-DE"/>
           </a:p>
@@ -2579,7 +2587,7 @@
           <a:p>
             <a:fld id="{B202D3EB-434C-7940-89BB-2B1A6C02241D}" type="datetimeFigureOut">
               <a:rPr lang="de-DE" smtClean="0"/>
-              <a:t>16.01.25</a:t>
+              <a:t>19.01.25</a:t>
             </a:fld>
             <a:endParaRPr lang="de-DE"/>
           </a:p>
@@ -2692,7 +2700,7 @@
           <a:p>
             <a:fld id="{B202D3EB-434C-7940-89BB-2B1A6C02241D}" type="datetimeFigureOut">
               <a:rPr lang="de-DE" smtClean="0"/>
-              <a:t>16.01.25</a:t>
+              <a:t>19.01.25</a:t>
             </a:fld>
             <a:endParaRPr lang="de-DE"/>
           </a:p>
@@ -3003,7 +3011,7 @@
           <a:p>
             <a:fld id="{B202D3EB-434C-7940-89BB-2B1A6C02241D}" type="datetimeFigureOut">
               <a:rPr lang="de-DE" smtClean="0"/>
-              <a:t>16.01.25</a:t>
+              <a:t>19.01.25</a:t>
             </a:fld>
             <a:endParaRPr lang="de-DE"/>
           </a:p>
@@ -3291,7 +3299,7 @@
           <a:p>
             <a:fld id="{B202D3EB-434C-7940-89BB-2B1A6C02241D}" type="datetimeFigureOut">
               <a:rPr lang="de-DE" smtClean="0"/>
-              <a:t>16.01.25</a:t>
+              <a:t>19.01.25</a:t>
             </a:fld>
             <a:endParaRPr lang="de-DE"/>
           </a:p>
@@ -3532,7 +3540,7 @@
           <a:p>
             <a:fld id="{B202D3EB-434C-7940-89BB-2B1A6C02241D}" type="datetimeFigureOut">
               <a:rPr lang="de-DE" smtClean="0"/>
-              <a:t>16.01.25</a:t>
+              <a:t>19.01.25</a:t>
             </a:fld>
             <a:endParaRPr lang="de-DE"/>
           </a:p>
@@ -4946,6 +4954,156 @@
 </p:sld>
 </file>
 
+<file path=ppt/slides/slide10.xml><?xml version="1.0" encoding="utf-8"?>
+<p:sld xmlns:a="http://schemas.openxmlformats.org/drawingml/2006/main" xmlns:r="http://schemas.openxmlformats.org/officeDocument/2006/relationships" xmlns:p="http://schemas.openxmlformats.org/presentationml/2006/main">
+  <p:cSld>
+    <p:spTree>
+      <p:nvGrpSpPr>
+        <p:cNvPr id="1" name=""/>
+        <p:cNvGrpSpPr/>
+        <p:nvPr/>
+      </p:nvGrpSpPr>
+      <p:grpSpPr>
+        <a:xfrm>
+          <a:off x="0" y="0"/>
+          <a:ext cx="0" cy="0"/>
+          <a:chOff x="0" y="0"/>
+          <a:chExt cx="0" cy="0"/>
+        </a:xfrm>
+      </p:grpSpPr>
+      <p:pic>
+        <p:nvPicPr>
+          <p:cNvPr id="3" name="Grafik 2">
+            <a:extLst>
+              <a:ext uri="{FF2B5EF4-FFF2-40B4-BE49-F238E27FC236}">
+                <a16:creationId xmlns:a16="http://schemas.microsoft.com/office/drawing/2014/main" id="{B074F2C8-1AD1-4F4F-E716-0D32A560C935}"/>
+              </a:ext>
+            </a:extLst>
+          </p:cNvPr>
+          <p:cNvPicPr>
+            <a:picLocks noChangeAspect="1"/>
+          </p:cNvPicPr>
+          <p:nvPr/>
+        </p:nvPicPr>
+        <p:blipFill>
+          <a:blip r:embed="rId2"/>
+          <a:stretch>
+            <a:fillRect/>
+          </a:stretch>
+        </p:blipFill>
+        <p:spPr>
+          <a:xfrm>
+            <a:off x="1098549" y="723624"/>
+            <a:ext cx="9531351" cy="5410752"/>
+          </a:xfrm>
+          <a:prstGeom prst="rect">
+            <a:avLst/>
+          </a:prstGeom>
+        </p:spPr>
+      </p:pic>
+    </p:spTree>
+    <p:extLst>
+      <p:ext uri="{BB962C8B-B14F-4D97-AF65-F5344CB8AC3E}">
+        <p14:creationId xmlns:p14="http://schemas.microsoft.com/office/powerpoint/2010/main" val="2990666644"/>
+      </p:ext>
+    </p:extLst>
+  </p:cSld>
+  <p:clrMapOvr>
+    <a:masterClrMapping/>
+  </p:clrMapOvr>
+</p:sld>
+</file>
+
+<file path=ppt/slides/slide11.xml><?xml version="1.0" encoding="utf-8"?>
+<p:sld xmlns:a="http://schemas.openxmlformats.org/drawingml/2006/main" xmlns:r="http://schemas.openxmlformats.org/officeDocument/2006/relationships" xmlns:p="http://schemas.openxmlformats.org/presentationml/2006/main">
+  <p:cSld>
+    <p:spTree>
+      <p:nvGrpSpPr>
+        <p:cNvPr id="1" name=""/>
+        <p:cNvGrpSpPr/>
+        <p:nvPr/>
+      </p:nvGrpSpPr>
+      <p:grpSpPr>
+        <a:xfrm>
+          <a:off x="0" y="0"/>
+          <a:ext cx="0" cy="0"/>
+          <a:chOff x="0" y="0"/>
+          <a:chExt cx="0" cy="0"/>
+        </a:xfrm>
+      </p:grpSpPr>
+      <p:pic>
+        <p:nvPicPr>
+          <p:cNvPr id="3" name="Grafik 2">
+            <a:extLst>
+              <a:ext uri="{FF2B5EF4-FFF2-40B4-BE49-F238E27FC236}">
+                <a16:creationId xmlns:a16="http://schemas.microsoft.com/office/drawing/2014/main" id="{DD35B781-7B6D-C28C-3991-30F98B3539DB}"/>
+              </a:ext>
+            </a:extLst>
+          </p:cNvPr>
+          <p:cNvPicPr>
+            <a:picLocks noChangeAspect="1"/>
+          </p:cNvPicPr>
+          <p:nvPr/>
+        </p:nvPicPr>
+        <p:blipFill>
+          <a:blip r:embed="rId2"/>
+          <a:stretch>
+            <a:fillRect/>
+          </a:stretch>
+        </p:blipFill>
+        <p:spPr>
+          <a:xfrm>
+            <a:off x="0" y="1638299"/>
+            <a:ext cx="6308842" cy="3581400"/>
+          </a:xfrm>
+          <a:prstGeom prst="rect">
+            <a:avLst/>
+          </a:prstGeom>
+        </p:spPr>
+      </p:pic>
+      <p:pic>
+        <p:nvPicPr>
+          <p:cNvPr id="5" name="Grafik 4">
+            <a:extLst>
+              <a:ext uri="{FF2B5EF4-FFF2-40B4-BE49-F238E27FC236}">
+                <a16:creationId xmlns:a16="http://schemas.microsoft.com/office/drawing/2014/main" id="{32D2EE99-7B04-08F6-E8D0-672A73F2E082}"/>
+              </a:ext>
+            </a:extLst>
+          </p:cNvPr>
+          <p:cNvPicPr>
+            <a:picLocks noChangeAspect="1"/>
+          </p:cNvPicPr>
+          <p:nvPr/>
+        </p:nvPicPr>
+        <p:blipFill>
+          <a:blip r:embed="rId3"/>
+          <a:stretch>
+            <a:fillRect/>
+          </a:stretch>
+        </p:blipFill>
+        <p:spPr>
+          <a:xfrm>
+            <a:off x="6308842" y="1803759"/>
+            <a:ext cx="5725906" cy="3250479"/>
+          </a:xfrm>
+          <a:prstGeom prst="rect">
+            <a:avLst/>
+          </a:prstGeom>
+        </p:spPr>
+      </p:pic>
+    </p:spTree>
+    <p:extLst>
+      <p:ext uri="{BB962C8B-B14F-4D97-AF65-F5344CB8AC3E}">
+        <p14:creationId xmlns:p14="http://schemas.microsoft.com/office/powerpoint/2010/main" val="3152487584"/>
+      </p:ext>
+    </p:extLst>
+  </p:cSld>
+  <p:clrMapOvr>
+    <a:masterClrMapping/>
+  </p:clrMapOvr>
+</p:sld>
+</file>
+
 <file path=ppt/slides/slide2.xml><?xml version="1.0" encoding="utf-8"?>
 <p:sld xmlns:a="http://schemas.openxmlformats.org/drawingml/2006/main" xmlns:r="http://schemas.openxmlformats.org/officeDocument/2006/relationships" xmlns:p="http://schemas.openxmlformats.org/presentationml/2006/main">
   <p:cSld>
@@ -6822,10 +6980,10 @@
       </p:sp>
       <p:pic>
         <p:nvPicPr>
-          <p:cNvPr id="6" name="Grafik 5">
-            <a:extLst>
-              <a:ext uri="{FF2B5EF4-FFF2-40B4-BE49-F238E27FC236}">
-                <a16:creationId xmlns:a16="http://schemas.microsoft.com/office/drawing/2014/main" id="{D31D0649-0C28-8F37-1E92-B0AC57D1433C}"/>
+          <p:cNvPr id="3" name="Grafik 2">
+            <a:extLst>
+              <a:ext uri="{FF2B5EF4-FFF2-40B4-BE49-F238E27FC236}">
+                <a16:creationId xmlns:a16="http://schemas.microsoft.com/office/drawing/2014/main" id="{61330D9E-A95C-0DAA-E255-03A891C607F3}"/>
               </a:ext>
             </a:extLst>
           </p:cNvPr>
@@ -6842,8 +7000,8 @@
         </p:blipFill>
         <p:spPr>
           <a:xfrm>
-            <a:off x="328529" y="740943"/>
-            <a:ext cx="9525334" cy="5628055"/>
+            <a:off x="427037" y="773295"/>
+            <a:ext cx="10302876" cy="5848731"/>
           </a:xfrm>
           <a:prstGeom prst="rect">
             <a:avLst/>
@@ -6880,10 +7038,194 @@
           <a:chExt cx="0" cy="0"/>
         </a:xfrm>
       </p:grpSpPr>
+      <p:pic>
+        <p:nvPicPr>
+          <p:cNvPr id="3" name="Grafik 2">
+            <a:extLst>
+              <a:ext uri="{FF2B5EF4-FFF2-40B4-BE49-F238E27FC236}">
+                <a16:creationId xmlns:a16="http://schemas.microsoft.com/office/drawing/2014/main" id="{855D78EA-8AAF-8B29-8ECE-3867B26ED4FE}"/>
+              </a:ext>
+            </a:extLst>
+          </p:cNvPr>
+          <p:cNvPicPr>
+            <a:picLocks noChangeAspect="1"/>
+          </p:cNvPicPr>
+          <p:nvPr/>
+        </p:nvPicPr>
+        <p:blipFill>
+          <a:blip r:embed="rId2"/>
+          <a:stretch>
+            <a:fillRect/>
+          </a:stretch>
+        </p:blipFill>
+        <p:spPr>
+          <a:xfrm>
+            <a:off x="498474" y="696418"/>
+            <a:ext cx="10350614" cy="5875832"/>
+          </a:xfrm>
+          <a:prstGeom prst="rect">
+            <a:avLst/>
+          </a:prstGeom>
+        </p:spPr>
+      </p:pic>
+      <p:sp>
+        <p:nvSpPr>
+          <p:cNvPr id="4" name="Textfeld 3">
+            <a:extLst>
+              <a:ext uri="{FF2B5EF4-FFF2-40B4-BE49-F238E27FC236}">
+                <a16:creationId xmlns:a16="http://schemas.microsoft.com/office/drawing/2014/main" id="{CBF5B1E1-ADE3-06F1-E023-D625B80DBFDD}"/>
+              </a:ext>
+            </a:extLst>
+          </p:cNvPr>
+          <p:cNvSpPr txBox="1"/>
+          <p:nvPr/>
+        </p:nvSpPr>
+        <p:spPr>
+          <a:xfrm>
+            <a:off x="371475" y="142875"/>
+            <a:ext cx="1843088" cy="369332"/>
+          </a:xfrm>
+          <a:prstGeom prst="rect">
+            <a:avLst/>
+          </a:prstGeom>
+          <a:noFill/>
+        </p:spPr>
+        <p:txBody>
+          <a:bodyPr wrap="square" rtlCol="0">
+            <a:spAutoFit/>
+          </a:bodyPr>
+          <a:lstStyle/>
+          <a:p>
+            <a:r>
+              <a:rPr lang="de-DE" dirty="0"/>
+              <a:t>PC 3 and PC 4</a:t>
+            </a:r>
+          </a:p>
+        </p:txBody>
+      </p:sp>
     </p:spTree>
     <p:extLst>
       <p:ext uri="{BB962C8B-B14F-4D97-AF65-F5344CB8AC3E}">
         <p14:creationId xmlns:p14="http://schemas.microsoft.com/office/powerpoint/2010/main" val="547071505"/>
+      </p:ext>
+    </p:extLst>
+  </p:cSld>
+  <p:clrMapOvr>
+    <a:masterClrMapping/>
+  </p:clrMapOvr>
+</p:sld>
+</file>
+
+<file path=ppt/slides/slide9.xml><?xml version="1.0" encoding="utf-8"?>
+<p:sld xmlns:a="http://schemas.openxmlformats.org/drawingml/2006/main" xmlns:r="http://schemas.openxmlformats.org/officeDocument/2006/relationships" xmlns:p="http://schemas.openxmlformats.org/presentationml/2006/main">
+  <p:cSld>
+    <p:spTree>
+      <p:nvGrpSpPr>
+        <p:cNvPr id="1" name=""/>
+        <p:cNvGrpSpPr/>
+        <p:nvPr/>
+      </p:nvGrpSpPr>
+      <p:grpSpPr>
+        <a:xfrm>
+          <a:off x="0" y="0"/>
+          <a:ext cx="0" cy="0"/>
+          <a:chOff x="0" y="0"/>
+          <a:chExt cx="0" cy="0"/>
+        </a:xfrm>
+      </p:grpSpPr>
+      <p:pic>
+        <p:nvPicPr>
+          <p:cNvPr id="3" name="Grafik 2">
+            <a:extLst>
+              <a:ext uri="{FF2B5EF4-FFF2-40B4-BE49-F238E27FC236}">
+                <a16:creationId xmlns:a16="http://schemas.microsoft.com/office/drawing/2014/main" id="{FFF4BEFF-8230-1E30-C63D-3676C619C5BA}"/>
+              </a:ext>
+            </a:extLst>
+          </p:cNvPr>
+          <p:cNvPicPr>
+            <a:picLocks noChangeAspect="1"/>
+          </p:cNvPicPr>
+          <p:nvPr/>
+        </p:nvPicPr>
+        <p:blipFill>
+          <a:blip r:embed="rId2"/>
+          <a:stretch>
+            <a:fillRect/>
+          </a:stretch>
+        </p:blipFill>
+        <p:spPr>
+          <a:xfrm>
+            <a:off x="1154633" y="781050"/>
+            <a:ext cx="9882733" cy="5610225"/>
+          </a:xfrm>
+          <a:prstGeom prst="rect">
+            <a:avLst/>
+          </a:prstGeom>
+        </p:spPr>
+      </p:pic>
+      <p:sp>
+        <p:nvSpPr>
+          <p:cNvPr id="4" name="Textfeld 3">
+            <a:extLst>
+              <a:ext uri="{FF2B5EF4-FFF2-40B4-BE49-F238E27FC236}">
+                <a16:creationId xmlns:a16="http://schemas.microsoft.com/office/drawing/2014/main" id="{54366AFF-0868-A621-9ACE-BABA82BFA380}"/>
+              </a:ext>
+            </a:extLst>
+          </p:cNvPr>
+          <p:cNvSpPr txBox="1"/>
+          <p:nvPr/>
+        </p:nvSpPr>
+        <p:spPr>
+          <a:xfrm>
+            <a:off x="371474" y="142875"/>
+            <a:ext cx="4029075" cy="369332"/>
+          </a:xfrm>
+          <a:prstGeom prst="rect">
+            <a:avLst/>
+          </a:prstGeom>
+          <a:noFill/>
+        </p:spPr>
+        <p:txBody>
+          <a:bodyPr wrap="square" rtlCol="0">
+            <a:spAutoFit/>
+          </a:bodyPr>
+          <a:lstStyle/>
+          <a:p>
+            <a:r>
+              <a:rPr lang="de-DE" dirty="0"/>
+              <a:t>PCA </a:t>
+            </a:r>
+            <a:r>
+              <a:rPr lang="de-DE" dirty="0" err="1"/>
+              <a:t>with</a:t>
+            </a:r>
+            <a:r>
+              <a:rPr lang="de-DE" dirty="0"/>
+              <a:t> </a:t>
+            </a:r>
+            <a:r>
+              <a:rPr lang="de-DE" dirty="0" err="1"/>
+              <a:t>aligned</a:t>
+            </a:r>
+            <a:r>
+              <a:rPr lang="de-DE" dirty="0"/>
+              <a:t> </a:t>
+            </a:r>
+            <a:r>
+              <a:rPr lang="de-DE" dirty="0" err="1"/>
+              <a:t>reads</a:t>
+            </a:r>
+            <a:r>
+              <a:rPr lang="de-DE" dirty="0"/>
+              <a:t> per sample</a:t>
+            </a:r>
+          </a:p>
+        </p:txBody>
+      </p:sp>
+    </p:spTree>
+    <p:extLst>
+      <p:ext uri="{BB962C8B-B14F-4D97-AF65-F5344CB8AC3E}">
+        <p14:creationId xmlns:p14="http://schemas.microsoft.com/office/powerpoint/2010/main" val="4041535115"/>
       </p:ext>
     </p:extLst>
   </p:cSld>

</xml_diff>

<commit_message>
preprocessing with missing samples
</commit_message>
<xml_diff>
--- a/progress.pptx
+++ b/progress.pptx
@@ -5,7 +5,7 @@
     <p:sldMasterId id="2147483648" r:id="rId1"/>
   </p:sldMasterIdLst>
   <p:notesMasterIdLst>
-    <p:notesMasterId r:id="rId14"/>
+    <p:notesMasterId r:id="rId15"/>
   </p:notesMasterIdLst>
   <p:sldIdLst>
     <p:sldId id="261" r:id="rId2"/>
@@ -20,6 +20,7 @@
     <p:sldId id="269" r:id="rId11"/>
     <p:sldId id="270" r:id="rId12"/>
     <p:sldId id="271" r:id="rId13"/>
+    <p:sldId id="273" r:id="rId14"/>
   </p:sldIdLst>
   <p:sldSz cx="12192000" cy="6858000"/>
   <p:notesSz cx="6858000" cy="9144000"/>
@@ -208,7 +209,7 @@
           <a:p>
             <a:fld id="{391F0B43-6B19-1044-8D4F-E46BB78FCD8B}" type="datetimeFigureOut">
               <a:rPr lang="de-DE" smtClean="0"/>
-              <a:t>20.01.25</a:t>
+              <a:t>27.01.25</a:t>
             </a:fld>
             <a:endParaRPr lang="de-DE"/>
           </a:p>
@@ -891,7 +892,7 @@
           <a:p>
             <a:fld id="{B202D3EB-434C-7940-89BB-2B1A6C02241D}" type="datetimeFigureOut">
               <a:rPr lang="de-DE" smtClean="0"/>
-              <a:t>20.01.25</a:t>
+              <a:t>27.01.25</a:t>
             </a:fld>
             <a:endParaRPr lang="de-DE"/>
           </a:p>
@@ -1089,7 +1090,7 @@
           <a:p>
             <a:fld id="{B202D3EB-434C-7940-89BB-2B1A6C02241D}" type="datetimeFigureOut">
               <a:rPr lang="de-DE" smtClean="0"/>
-              <a:t>20.01.25</a:t>
+              <a:t>27.01.25</a:t>
             </a:fld>
             <a:endParaRPr lang="de-DE"/>
           </a:p>
@@ -1297,7 +1298,7 @@
           <a:p>
             <a:fld id="{B202D3EB-434C-7940-89BB-2B1A6C02241D}" type="datetimeFigureOut">
               <a:rPr lang="de-DE" smtClean="0"/>
-              <a:t>20.01.25</a:t>
+              <a:t>27.01.25</a:t>
             </a:fld>
             <a:endParaRPr lang="de-DE"/>
           </a:p>
@@ -1495,7 +1496,7 @@
           <a:p>
             <a:fld id="{B202D3EB-434C-7940-89BB-2B1A6C02241D}" type="datetimeFigureOut">
               <a:rPr lang="de-DE" smtClean="0"/>
-              <a:t>20.01.25</a:t>
+              <a:t>27.01.25</a:t>
             </a:fld>
             <a:endParaRPr lang="de-DE"/>
           </a:p>
@@ -1770,7 +1771,7 @@
           <a:p>
             <a:fld id="{B202D3EB-434C-7940-89BB-2B1A6C02241D}" type="datetimeFigureOut">
               <a:rPr lang="de-DE" smtClean="0"/>
-              <a:t>20.01.25</a:t>
+              <a:t>27.01.25</a:t>
             </a:fld>
             <a:endParaRPr lang="de-DE"/>
           </a:p>
@@ -2035,7 +2036,7 @@
           <a:p>
             <a:fld id="{B202D3EB-434C-7940-89BB-2B1A6C02241D}" type="datetimeFigureOut">
               <a:rPr lang="de-DE" smtClean="0"/>
-              <a:t>20.01.25</a:t>
+              <a:t>27.01.25</a:t>
             </a:fld>
             <a:endParaRPr lang="de-DE"/>
           </a:p>
@@ -2447,7 +2448,7 @@
           <a:p>
             <a:fld id="{B202D3EB-434C-7940-89BB-2B1A6C02241D}" type="datetimeFigureOut">
               <a:rPr lang="de-DE" smtClean="0"/>
-              <a:t>20.01.25</a:t>
+              <a:t>27.01.25</a:t>
             </a:fld>
             <a:endParaRPr lang="de-DE"/>
           </a:p>
@@ -2588,7 +2589,7 @@
           <a:p>
             <a:fld id="{B202D3EB-434C-7940-89BB-2B1A6C02241D}" type="datetimeFigureOut">
               <a:rPr lang="de-DE" smtClean="0"/>
-              <a:t>20.01.25</a:t>
+              <a:t>27.01.25</a:t>
             </a:fld>
             <a:endParaRPr lang="de-DE"/>
           </a:p>
@@ -2701,7 +2702,7 @@
           <a:p>
             <a:fld id="{B202D3EB-434C-7940-89BB-2B1A6C02241D}" type="datetimeFigureOut">
               <a:rPr lang="de-DE" smtClean="0"/>
-              <a:t>20.01.25</a:t>
+              <a:t>27.01.25</a:t>
             </a:fld>
             <a:endParaRPr lang="de-DE"/>
           </a:p>
@@ -3012,7 +3013,7 @@
           <a:p>
             <a:fld id="{B202D3EB-434C-7940-89BB-2B1A6C02241D}" type="datetimeFigureOut">
               <a:rPr lang="de-DE" smtClean="0"/>
-              <a:t>20.01.25</a:t>
+              <a:t>27.01.25</a:t>
             </a:fld>
             <a:endParaRPr lang="de-DE"/>
           </a:p>
@@ -3300,7 +3301,7 @@
           <a:p>
             <a:fld id="{B202D3EB-434C-7940-89BB-2B1A6C02241D}" type="datetimeFigureOut">
               <a:rPr lang="de-DE" smtClean="0"/>
-              <a:t>20.01.25</a:t>
+              <a:t>27.01.25</a:t>
             </a:fld>
             <a:endParaRPr lang="de-DE"/>
           </a:p>
@@ -3541,7 +3542,7 @@
           <a:p>
             <a:fld id="{B202D3EB-434C-7940-89BB-2B1A6C02241D}" type="datetimeFigureOut">
               <a:rPr lang="de-DE" smtClean="0"/>
-              <a:t>20.01.25</a:t>
+              <a:t>27.01.25</a:t>
             </a:fld>
             <a:endParaRPr lang="de-DE"/>
           </a:p>
@@ -5264,6 +5265,36 @@
     <p:extLst>
       <p:ext uri="{BB962C8B-B14F-4D97-AF65-F5344CB8AC3E}">
         <p14:creationId xmlns:p14="http://schemas.microsoft.com/office/powerpoint/2010/main" val="3152487584"/>
+      </p:ext>
+    </p:extLst>
+  </p:cSld>
+  <p:clrMapOvr>
+    <a:masterClrMapping/>
+  </p:clrMapOvr>
+</p:sld>
+</file>
+
+<file path=ppt/slides/slide13.xml><?xml version="1.0" encoding="utf-8"?>
+<p:sld xmlns:a="http://schemas.openxmlformats.org/drawingml/2006/main" xmlns:r="http://schemas.openxmlformats.org/officeDocument/2006/relationships" xmlns:p="http://schemas.openxmlformats.org/presentationml/2006/main">
+  <p:cSld>
+    <p:spTree>
+      <p:nvGrpSpPr>
+        <p:cNvPr id="1" name=""/>
+        <p:cNvGrpSpPr/>
+        <p:nvPr/>
+      </p:nvGrpSpPr>
+      <p:grpSpPr>
+        <a:xfrm>
+          <a:off x="0" y="0"/>
+          <a:ext cx="0" cy="0"/>
+          <a:chOff x="0" y="0"/>
+          <a:chExt cx="0" cy="0"/>
+        </a:xfrm>
+      </p:grpSpPr>
+    </p:spTree>
+    <p:extLst>
+      <p:ext uri="{BB962C8B-B14F-4D97-AF65-F5344CB8AC3E}">
+        <p14:creationId xmlns:p14="http://schemas.microsoft.com/office/powerpoint/2010/main" val="1686439885"/>
       </p:ext>
     </p:extLst>
   </p:cSld>

</xml_diff>